<commit_message>
Simplify the summary slide
Co-Authored-By: Claude Opus 5.5 <noreply@anthropic.com>
</commit_message>
<xml_diff>
--- a/presentation/MineralWater_Presentation.pptx
+++ b/presentation/MineralWater_Presentation.pptx
@@ -777,7 +777,7 @@
           <a:p>
             <a:r>
               <a:rPr lang="en-US" dirty="0"/>
-              <a:t>สรุปคือ Graph Database เหมาะกับโจทย์ระบบแนะนำ เพราะเขียนคำถามเป็นเส้นทางได้ตรงตัว คำแนะนำอธิบายที่มาได้ และระบบใช้งานได้จริงบนเว็บ ขอบคุณค่ะ</a:t>
+              <a:t>สรุปสั้น ๆ คือ ระบบนี้แนะนำน้ำแร่ที่ลูกค้าน่าจะชอบโดยดูจากคนที่ชอบคล้ายกัน เราเก็บข้อมูลเป็นกราฟ คือลูกค้าและน้ำแร่เป็นจุด เชื่อมกันด้วยเส้นชอบและเส้นคล้ายกัน เมื่อคนที่คล้ายเราชอบยี่ห้อไหน ระบบก็แนะนำยี่ห้อนั้น และทั้งหมดใช้งานผ่านเว็บได้ทันที ขอบคุณค่ะ</a:t>
             </a:r>
             <a:endParaRPr lang="en-US" dirty="0"/>
           </a:p>
@@ -3731,13 +3731,52 @@
       </p:sp>
       <p:sp>
         <p:nvSpPr>
-          <p:cNvPr id="3" name="Shape 1"/>
+          <p:cNvPr id="3" name="Text 1"/>
+          <p:cNvSpPr txBox="1"/>
+          <p:nvPr/>
+        </p:nvSpPr>
+        <p:spPr>
+          <a:xfrm>
+            <a:off x="640080" y="1115568"/>
+            <a:ext cx="7863840" cy="365760"/>
+          </a:xfrm>
+          <a:prstGeom prst="rect">
+            <a:avLst/>
+          </a:prstGeom>
+          <a:noFill/>
+          <a:ln/>
+        </p:spPr>
+        <p:txBody>
+          <a:bodyPr wrap="square" lIns="0" tIns="0" rIns="0" bIns="0" rtlCol="0" anchor="ctr"/>
+          <a:lstStyle/>
+          <a:p>
+            <a:pPr indent="0" marL="0">
+              <a:buNone/>
+            </a:pPr>
+            <a:r>
+              <a:rPr lang="en-US" sz="1600" dirty="0">
+                <a:solidFill>
+                  <a:srgbClr val="E8F7FB"/>
+                </a:solidFill>
+                <a:latin typeface="Tahoma" pitchFamily="34" charset="0"/>
+                <a:ea typeface="Tahoma" pitchFamily="34" charset="-122"/>
+                <a:cs typeface="Tahoma" pitchFamily="34" charset="-120"/>
+              </a:rPr>
+              <a:t>ระบบนี้แนะนำน้ำแร่ที่ลูกค้าน่าจะชอบ โดยดูจากคนที่ชอบคล้ายกัน</a:t>
+            </a:r>
+            <a:endParaRPr lang="en-US" sz="1600" dirty="0"/>
+          </a:p>
+        </p:txBody>
+      </p:sp>
+      <p:sp>
+        <p:nvSpPr>
+          <p:cNvPr id="4" name="Shape 2"/>
           <p:cNvSpPr/>
           <p:nvPr/>
         </p:nvSpPr>
         <p:spPr>
           <a:xfrm>
-            <a:off x="640080" y="1362456"/>
+            <a:off x="640080" y="1773936"/>
             <a:ext cx="420624" cy="420624"/>
           </a:xfrm>
           <a:prstGeom prst="ellipse">
@@ -3756,13 +3795,13 @@
       </p:sp>
       <p:sp>
         <p:nvSpPr>
-          <p:cNvPr id="4" name="Text 2"/>
-          <p:cNvSpPr txBox="1"/>
-          <p:nvPr/>
-        </p:nvSpPr>
-        <p:spPr>
-          <a:xfrm>
-            <a:off x="640080" y="1362456"/>
+          <p:cNvPr id="5" name="Text 3"/>
+          <p:cNvSpPr txBox="1"/>
+          <p:nvPr/>
+        </p:nvSpPr>
+        <p:spPr>
+          <a:xfrm>
+            <a:off x="640080" y="1773936"/>
             <a:ext cx="420624" cy="420624"/>
           </a:xfrm>
           <a:prstGeom prst="rect">
@@ -3795,13 +3834,13 @@
       </p:sp>
       <p:sp>
         <p:nvSpPr>
-          <p:cNvPr id="5" name="Text 3"/>
-          <p:cNvSpPr txBox="1"/>
-          <p:nvPr/>
-        </p:nvSpPr>
-        <p:spPr>
-          <a:xfrm>
-            <a:off x="1234440" y="1325880"/>
+          <p:cNvPr id="6" name="Text 4"/>
+          <p:cNvSpPr txBox="1"/>
+          <p:nvPr/>
+        </p:nvSpPr>
+        <p:spPr>
+          <a:xfrm>
+            <a:off x="1234440" y="1719072"/>
             <a:ext cx="7132320" cy="274320"/>
           </a:xfrm>
           <a:prstGeom prst="rect">
@@ -3826,7 +3865,7 @@
                 <a:ea typeface="Tahoma" pitchFamily="34" charset="-122"/>
                 <a:cs typeface="Tahoma" pitchFamily="34" charset="-120"/>
               </a:rPr>
-              <a:t>Graph เหมาะกับโจทย์แนะนำ</a:t>
+              <a:t>เก็บข้อมูลเป็นกราฟ</a:t>
             </a:r>
             <a:endParaRPr lang="en-US" sz="1500" dirty="0"/>
           </a:p>
@@ -3834,14 +3873,14 @@
       </p:sp>
       <p:sp>
         <p:nvSpPr>
-          <p:cNvPr id="6" name="Text 4"/>
-          <p:cNvSpPr txBox="1"/>
-          <p:nvPr/>
-        </p:nvSpPr>
-        <p:spPr>
-          <a:xfrm>
-            <a:off x="1234440" y="1627632"/>
-            <a:ext cx="7132320" cy="274320"/>
+          <p:cNvPr id="7" name="Text 5"/>
+          <p:cNvSpPr txBox="1"/>
+          <p:nvPr/>
+        </p:nvSpPr>
+        <p:spPr>
+          <a:xfrm>
+            <a:off x="1234440" y="2011680"/>
+            <a:ext cx="7132320" cy="256032"/>
           </a:xfrm>
           <a:prstGeom prst="rect">
             <a:avLst/>
@@ -3857,7 +3896,7 @@
               <a:buNone/>
             </a:pPr>
             <a:r>
-              <a:rPr lang="en-US" sz="1150" dirty="0">
+              <a:rPr lang="en-US" sz="1200" dirty="0">
                 <a:solidFill>
                   <a:srgbClr val="E8F7FB"/>
                 </a:solidFill>
@@ -3865,21 +3904,21 @@
                 <a:ea typeface="Tahoma" pitchFamily="34" charset="-122"/>
                 <a:cs typeface="Tahoma" pitchFamily="34" charset="-120"/>
               </a:rPr>
-              <a:t>คำถาม "คนที่คล้ายกันชอบอะไร" เขียนเป็นเส้นทางใน Cypher ได้ตรงตัว</a:t>
-            </a:r>
-            <a:endParaRPr lang="en-US" sz="1150" dirty="0"/>
-          </a:p>
-        </p:txBody>
-      </p:sp>
-      <p:sp>
-        <p:nvSpPr>
-          <p:cNvPr id="7" name="Shape 5"/>
+              <a:t>ลูกค้าและน้ำแร่เป็นจุด เชื่อมกันด้วยเส้น "ชอบ" และ "คล้ายกัน"</a:t>
+            </a:r>
+            <a:endParaRPr lang="en-US" sz="1200" dirty="0"/>
+          </a:p>
+        </p:txBody>
+      </p:sp>
+      <p:sp>
+        <p:nvSpPr>
+          <p:cNvPr id="8" name="Shape 6"/>
           <p:cNvSpPr/>
           <p:nvPr/>
         </p:nvSpPr>
         <p:spPr>
           <a:xfrm>
-            <a:off x="640080" y="2185416"/>
+            <a:off x="640080" y="2468880"/>
             <a:ext cx="420624" cy="420624"/>
           </a:xfrm>
           <a:prstGeom prst="ellipse">
@@ -3898,13 +3937,13 @@
       </p:sp>
       <p:sp>
         <p:nvSpPr>
-          <p:cNvPr id="8" name="Text 6"/>
-          <p:cNvSpPr txBox="1"/>
-          <p:nvPr/>
-        </p:nvSpPr>
-        <p:spPr>
-          <a:xfrm>
-            <a:off x="640080" y="2185416"/>
+          <p:cNvPr id="9" name="Text 7"/>
+          <p:cNvSpPr txBox="1"/>
+          <p:nvPr/>
+        </p:nvSpPr>
+        <p:spPr>
+          <a:xfrm>
+            <a:off x="640080" y="2468880"/>
             <a:ext cx="420624" cy="420624"/>
           </a:xfrm>
           <a:prstGeom prst="rect">
@@ -3937,13 +3976,13 @@
       </p:sp>
       <p:sp>
         <p:nvSpPr>
-          <p:cNvPr id="9" name="Text 7"/>
-          <p:cNvSpPr txBox="1"/>
-          <p:nvPr/>
-        </p:nvSpPr>
-        <p:spPr>
-          <a:xfrm>
-            <a:off x="1234440" y="2148840"/>
+          <p:cNvPr id="10" name="Text 8"/>
+          <p:cNvSpPr txBox="1"/>
+          <p:nvPr/>
+        </p:nvSpPr>
+        <p:spPr>
+          <a:xfrm>
+            <a:off x="1234440" y="2414016"/>
             <a:ext cx="7132320" cy="274320"/>
           </a:xfrm>
           <a:prstGeom prst="rect">
@@ -3968,7 +4007,7 @@
                 <a:ea typeface="Tahoma" pitchFamily="34" charset="-122"/>
                 <a:cs typeface="Tahoma" pitchFamily="34" charset="-120"/>
               </a:rPr>
-              <a:t>คำแนะนำอธิบายได้</a:t>
+              <a:t>แนะนำจากคนที่คล้ายกัน</a:t>
             </a:r>
             <a:endParaRPr lang="en-US" sz="1500" dirty="0"/>
           </a:p>
@@ -3976,14 +4015,14 @@
       </p:sp>
       <p:sp>
         <p:nvSpPr>
-          <p:cNvPr id="10" name="Text 8"/>
-          <p:cNvSpPr txBox="1"/>
-          <p:nvPr/>
-        </p:nvSpPr>
-        <p:spPr>
-          <a:xfrm>
-            <a:off x="1234440" y="2450592"/>
-            <a:ext cx="7132320" cy="274320"/>
+          <p:cNvPr id="11" name="Text 9"/>
+          <p:cNvSpPr txBox="1"/>
+          <p:nvPr/>
+        </p:nvSpPr>
+        <p:spPr>
+          <a:xfrm>
+            <a:off x="1234440" y="2706624"/>
+            <a:ext cx="7132320" cy="256032"/>
           </a:xfrm>
           <a:prstGeom prst="rect">
             <a:avLst/>
@@ -3999,7 +4038,7 @@
               <a:buNone/>
             </a:pPr>
             <a:r>
-              <a:rPr lang="en-US" sz="1150" dirty="0">
+              <a:rPr lang="en-US" sz="1200" dirty="0">
                 <a:solidFill>
                   <a:srgbClr val="E8F7FB"/>
                 </a:solidFill>
@@ -4007,21 +4046,21 @@
                 <a:ea typeface="Tahoma" pitchFamily="34" charset="-122"/>
                 <a:cs typeface="Tahoma" pitchFamily="34" charset="-120"/>
               </a:rPr>
-              <a:t>ทุกคำแนะนำบอกได้ว่ามาจากลูกค้าคนใด</a:t>
-            </a:r>
-            <a:endParaRPr lang="en-US" sz="1150" dirty="0"/>
-          </a:p>
-        </p:txBody>
-      </p:sp>
-      <p:sp>
-        <p:nvSpPr>
-          <p:cNvPr id="11" name="Shape 9"/>
+              <a:t>คนที่คล้ายเราชอบยี่ห้อไหน ระบบก็แนะนำยี่ห้อนั้นให้เรา</a:t>
+            </a:r>
+            <a:endParaRPr lang="en-US" sz="1200" dirty="0"/>
+          </a:p>
+        </p:txBody>
+      </p:sp>
+      <p:sp>
+        <p:nvSpPr>
+          <p:cNvPr id="12" name="Shape 10"/>
           <p:cNvSpPr/>
           <p:nvPr/>
         </p:nvSpPr>
         <p:spPr>
           <a:xfrm>
-            <a:off x="640080" y="3008376"/>
+            <a:off x="640080" y="3163824"/>
             <a:ext cx="420624" cy="420624"/>
           </a:xfrm>
           <a:prstGeom prst="ellipse">
@@ -4040,13 +4079,13 @@
       </p:sp>
       <p:sp>
         <p:nvSpPr>
-          <p:cNvPr id="12" name="Text 10"/>
-          <p:cNvSpPr txBox="1"/>
-          <p:nvPr/>
-        </p:nvSpPr>
-        <p:spPr>
-          <a:xfrm>
-            <a:off x="640080" y="3008376"/>
+          <p:cNvPr id="13" name="Text 11"/>
+          <p:cNvSpPr txBox="1"/>
+          <p:nvPr/>
+        </p:nvSpPr>
+        <p:spPr>
+          <a:xfrm>
+            <a:off x="640080" y="3163824"/>
             <a:ext cx="420624" cy="420624"/>
           </a:xfrm>
           <a:prstGeom prst="rect">
@@ -4079,13 +4118,13 @@
       </p:sp>
       <p:sp>
         <p:nvSpPr>
-          <p:cNvPr id="13" name="Text 11"/>
-          <p:cNvSpPr txBox="1"/>
-          <p:nvPr/>
-        </p:nvSpPr>
-        <p:spPr>
-          <a:xfrm>
-            <a:off x="1234440" y="2971800"/>
+          <p:cNvPr id="14" name="Text 12"/>
+          <p:cNvSpPr txBox="1"/>
+          <p:nvPr/>
+        </p:nvSpPr>
+        <p:spPr>
+          <a:xfrm>
+            <a:off x="1234440" y="3108960"/>
             <a:ext cx="7132320" cy="274320"/>
           </a:xfrm>
           <a:prstGeom prst="rect">
@@ -4110,7 +4149,7 @@
                 <a:ea typeface="Tahoma" pitchFamily="34" charset="-122"/>
                 <a:cs typeface="Tahoma" pitchFamily="34" charset="-120"/>
               </a:rPr>
-              <a:t>ใช้งานได้จริงบนเว็บ</a:t>
+              <a:t>ใช้งานผ่านเว็บได้ทันที</a:t>
             </a:r>
             <a:endParaRPr lang="en-US" sz="1500" dirty="0"/>
           </a:p>
@@ -4118,14 +4157,14 @@
       </p:sp>
       <p:sp>
         <p:nvSpPr>
-          <p:cNvPr id="14" name="Text 12"/>
-          <p:cNvSpPr txBox="1"/>
-          <p:nvPr/>
-        </p:nvSpPr>
-        <p:spPr>
-          <a:xfrm>
-            <a:off x="1234440" y="3273552"/>
-            <a:ext cx="7132320" cy="274320"/>
+          <p:cNvPr id="15" name="Text 13"/>
+          <p:cNvSpPr txBox="1"/>
+          <p:nvPr/>
+        </p:nvSpPr>
+        <p:spPr>
+          <a:xfrm>
+            <a:off x="1234440" y="3401568"/>
+            <a:ext cx="7132320" cy="256032"/>
           </a:xfrm>
           <a:prstGeom prst="rect">
             <a:avLst/>
@@ -4141,7 +4180,7 @@
               <a:buNone/>
             </a:pPr>
             <a:r>
-              <a:rPr lang="en-US" sz="1150" dirty="0">
+              <a:rPr lang="en-US" sz="1200" dirty="0">
                 <a:solidFill>
                   <a:srgbClr val="E8F7FB"/>
                 </a:solidFill>
@@ -4149,15 +4188,15 @@
                 <a:ea typeface="Tahoma" pitchFamily="34" charset="-122"/>
                 <a:cs typeface="Tahoma" pitchFamily="34" charset="-120"/>
               </a:rPr>
-              <a:t>จัดการข้อมูลได้ครบ และเปิดดูการบ้านทั้ง 3 ชิ้นได้ในเว็บเดียว</a:t>
-            </a:r>
-            <a:endParaRPr lang="en-US" sz="1150" dirty="0"/>
-          </a:p>
-        </p:txBody>
-      </p:sp>
-      <p:sp>
-        <p:nvSpPr>
-          <p:cNvPr id="15" name="Shape 13"/>
+              <a:t>เพิ่ม ลบ แก้ไขข้อมูล แล้วดูคำแนะนำได้เลย</a:t>
+            </a:r>
+            <a:endParaRPr lang="en-US" sz="1200" dirty="0"/>
+          </a:p>
+        </p:txBody>
+      </p:sp>
+      <p:sp>
+        <p:nvSpPr>
+          <p:cNvPr id="16" name="Shape 14"/>
           <p:cNvSpPr/>
           <p:nvPr/>
         </p:nvSpPr>
@@ -4186,7 +4225,7 @@
       </p:sp>
       <p:sp>
         <p:nvSpPr>
-          <p:cNvPr id="16" name="Text 14"/>
+          <p:cNvPr id="17" name="Text 15"/>
           <p:cNvSpPr txBox="1"/>
           <p:nvPr/>
         </p:nvSpPr>

</xml_diff>